<commit_message>
docs(perf): clarify sampling and counter explanations
</commit_message>
<xml_diff>
--- a/docs/presentations/starryos-perf.pptx
+++ b/docs/presentations/starryos-perf.pptx
@@ -10495,7 +10495,7 @@
                 <a:latin typeface="Arial" panose="020B0604020202020204" pitchFamily="34" charset="0"/>
                 <a:cs typeface="Arial" panose="020B0604020202020204" pitchFamily="34" charset="0"/>
               </a:rPr>
-              <a:t>：保存计数，释放硬件位置</a:t>
+              <a:t>：保存计数，停用计数器</a:t>
             </a:r>
           </a:p>
           <a:p>
@@ -10525,7 +10525,7 @@
                 <a:latin typeface="Arial" panose="020B0604020202020204" pitchFamily="34" charset="0"/>
                 <a:cs typeface="Arial" panose="020B0604020202020204" pitchFamily="34" charset="0"/>
               </a:rPr>
-              <a:t>：申请位置，恢复测量</a:t>
+              <a:t>：分配计数器，恢复测量</a:t>
             </a:r>
             <a:endParaRPr lang="en-CN" sz="2200" dirty="0">
               <a:latin typeface="Arial" panose="020B0604020202020204" pitchFamily="34" charset="0"/>
@@ -12313,14 +12313,21 @@
                 <a:latin typeface="Arial" panose="020B0604020202020204" pitchFamily="34" charset="0"/>
                 <a:cs typeface="Arial" panose="020B0604020202020204" pitchFamily="34" charset="0"/>
               </a:rPr>
-              <a:t>选择位置 </a:t>
+              <a:t>选择 </a:t>
             </a:r>
             <a:r>
               <a:rPr lang="en-US" altLang="zh-CN" sz="2200" dirty="0">
                 <a:latin typeface="Arial" panose="020B0604020202020204" pitchFamily="34" charset="0"/>
                 <a:cs typeface="Arial" panose="020B0604020202020204" pitchFamily="34" charset="0"/>
               </a:rPr>
-              <a:t>0–5</a:t>
+              <a:t>0–5 </a:t>
+            </a:r>
+            <a:r>
+              <a:rPr lang="zh-CN" altLang="en-US" sz="2200" dirty="0">
+                <a:latin typeface="Arial" panose="020B0604020202020204" pitchFamily="34" charset="0"/>
+                <a:cs typeface="Arial" panose="020B0604020202020204" pitchFamily="34" charset="0"/>
+              </a:rPr>
+              <a:t>号计数器</a:t>
             </a:r>
             <a:endParaRPr lang="en-CN" sz="2200" dirty="0">
               <a:latin typeface="Arial" panose="020B0604020202020204" pitchFamily="34" charset="0"/>
@@ -17704,7 +17711,7 @@
                 <a:latin typeface="Arial" panose="020B0604020202020204" pitchFamily="34" charset="0"/>
                 <a:cs typeface="Arial" panose="020B0604020202020204" pitchFamily="34" charset="0"/>
               </a:rPr>
-              <a:t>，调出时再累计完整片段</a:t>
+              <a:t>，调出时累计本次运行的计数</a:t>
             </a:r>
             <a:endParaRPr lang="en-CN" sz="2200" dirty="0">
               <a:latin typeface="Arial" panose="020B0604020202020204" pitchFamily="34" charset="0"/>
@@ -19346,7 +19353,7 @@
                 <a:ea typeface="Microsoft YaHei UI"/>
                 <a:cs typeface="Arial"/>
               </a:rPr>
-              <a:t>下一轮分配硬件位置</a:t>
+              <a:t>下一轮分配计数器</a:t>
             </a:r>
             <a:endParaRPr lang="zh-CN" altLang="en-US" sz="3200" b="0" dirty="0">
               <a:latin typeface="Arial"/>
@@ -21077,7 +21084,7 @@
           <a:lstStyle/>
           <a:p>
             <a:r>
-              <a:rPr lang="en-US" sz="2100">
+              <a:rPr lang="en-US" sz="2100" dirty="0">
                 <a:latin typeface="Microsoft YaHei UI" panose="020B0503020204020204" pitchFamily="34" charset="-122"/>
                 <a:ea typeface="Microsoft YaHei UI" panose="020B0503020204020204" pitchFamily="34" charset="-122"/>
                 <a:cs typeface="Arial" panose="020B0604020202020204" pitchFamily="34" charset="0"/>
@@ -21148,7 +21155,7 @@
                 <a:ea typeface="Microsoft YaHei UI" panose="020B0503020204020204" pitchFamily="34" charset="-122"/>
                 <a:cs typeface="Arial" panose="020B0604020202020204" pitchFamily="34" charset="0"/>
               </a:rPr>
-              <a:t>个可分配位置</a:t>
+              <a:t>个可分配计数器</a:t>
             </a:r>
           </a:p>
           <a:p>
@@ -21576,7 +21583,7 @@
                 <a:latin typeface="Arial" panose="020B0604020202020204" pitchFamily="34" charset="0"/>
                 <a:cs typeface="Arial" panose="020B0604020202020204" pitchFamily="34" charset="0"/>
               </a:rPr>
-              <a:t>，每累计 </a:t>
+              <a:t>，连续计数增加 </a:t>
             </a:r>
             <a:r>
               <a:rPr lang="en-US" altLang="zh-CN" sz="2200" dirty="0">
@@ -21590,130 +21597,74 @@
                 <a:latin typeface="Arial" panose="020B0604020202020204" pitchFamily="34" charset="0"/>
                 <a:cs typeface="Arial" panose="020B0604020202020204" pitchFamily="34" charset="0"/>
               </a:rPr>
-              <a:t>个事件采样 </a:t>
-            </a:r>
+              <a:t>次后请求中断</a:t>
+            </a:r>
+          </a:p>
+          <a:p>
             <a:r>
               <a:rPr lang="en-US" altLang="zh-CN" sz="2200" dirty="0">
                 <a:latin typeface="Arial" panose="020B0604020202020204" pitchFamily="34" charset="0"/>
                 <a:cs typeface="Arial" panose="020B0604020202020204" pitchFamily="34" charset="0"/>
               </a:rPr>
-              <a:t>1 </a:t>
+              <a:t>8 </a:t>
             </a:r>
             <a:r>
               <a:rPr lang="zh-CN" altLang="en-US" sz="2200" dirty="0">
                 <a:latin typeface="Arial" panose="020B0604020202020204" pitchFamily="34" charset="0"/>
                 <a:cs typeface="Arial" panose="020B0604020202020204" pitchFamily="34" charset="0"/>
               </a:rPr>
-              <a:t>次</a:t>
-            </a:r>
-          </a:p>
-          <a:p>
+              <a:t>位初值为 </a:t>
+            </a:r>
             <a:r>
               <a:rPr lang="en-US" altLang="zh-CN" sz="2200" dirty="0">
                 <a:latin typeface="Arial" panose="020B0604020202020204" pitchFamily="34" charset="0"/>
                 <a:cs typeface="Arial" panose="020B0604020202020204" pitchFamily="34" charset="0"/>
               </a:rPr>
-              <a:t>8 </a:t>
+              <a:t>256 − 20 = 236</a:t>
             </a:r>
             <a:r>
               <a:rPr lang="zh-CN" altLang="en-US" sz="2200" dirty="0">
                 <a:latin typeface="Arial" panose="020B0604020202020204" pitchFamily="34" charset="0"/>
                 <a:cs typeface="Arial" panose="020B0604020202020204" pitchFamily="34" charset="0"/>
               </a:rPr>
-              <a:t>位初值为 </a:t>
+              <a:t>；</a:t>
             </a:r>
             <a:r>
               <a:rPr lang="en-US" altLang="zh-CN" sz="2200" dirty="0">
                 <a:latin typeface="Arial" panose="020B0604020202020204" pitchFamily="34" charset="0"/>
                 <a:cs typeface="Arial" panose="020B0604020202020204" pitchFamily="34" charset="0"/>
               </a:rPr>
-              <a:t>256 − 20 = 236</a:t>
+              <a:t>32 </a:t>
             </a:r>
             <a:r>
               <a:rPr lang="zh-CN" altLang="en-US" sz="2200" dirty="0">
                 <a:latin typeface="Arial" panose="020B0604020202020204" pitchFamily="34" charset="0"/>
                 <a:cs typeface="Arial" panose="020B0604020202020204" pitchFamily="34" charset="0"/>
               </a:rPr>
-              <a:t>；</a:t>
+              <a:t>位初值为 </a:t>
             </a:r>
             <a:r>
               <a:rPr lang="en-US" altLang="zh-CN" sz="2200" dirty="0">
                 <a:latin typeface="Arial" panose="020B0604020202020204" pitchFamily="34" charset="0"/>
                 <a:cs typeface="Arial" panose="020B0604020202020204" pitchFamily="34" charset="0"/>
               </a:rPr>
-              <a:t>32 </a:t>
-            </a:r>
+              <a:t>2³² − period</a:t>
+            </a:r>
+          </a:p>
+          <a:p>
             <a:r>
               <a:rPr lang="zh-CN" altLang="en-US" sz="2200" dirty="0">
                 <a:latin typeface="Arial" panose="020B0604020202020204" pitchFamily="34" charset="0"/>
                 <a:cs typeface="Arial" panose="020B0604020202020204" pitchFamily="34" charset="0"/>
               </a:rPr>
-              <a:t>位初值为 </a:t>
+              <a:t>当前实现调出时未保存剩余间隔，重新调入后重设完整 </a:t>
             </a:r>
             <a:r>
               <a:rPr lang="en-US" altLang="zh-CN" sz="2200" dirty="0">
                 <a:latin typeface="Arial" panose="020B0604020202020204" pitchFamily="34" charset="0"/>
                 <a:cs typeface="Arial" panose="020B0604020202020204" pitchFamily="34" charset="0"/>
               </a:rPr>
-              <a:t>2³² − period</a:t>
-            </a:r>
-          </a:p>
-          <a:p>
-            <a:r>
-              <a:rPr lang="zh-CN" altLang="en-US" sz="2200" dirty="0">
-                <a:latin typeface="Arial" panose="020B0604020202020204" pitchFamily="34" charset="0"/>
-                <a:cs typeface="Arial" panose="020B0604020202020204" pitchFamily="34" charset="0"/>
-              </a:rPr>
-              <a:t>板级 </a:t>
-            </a:r>
-            <a:r>
-              <a:rPr lang="en-US" altLang="zh-CN" sz="2200" dirty="0" err="1">
-                <a:latin typeface="Arial" panose="020B0604020202020204" pitchFamily="34" charset="0"/>
-                <a:cs typeface="Arial" panose="020B0604020202020204" pitchFamily="34" charset="0"/>
-              </a:rPr>
-              <a:t>freq</a:t>
-            </a:r>
-            <a:r>
-              <a:rPr lang="en-US" altLang="zh-CN" sz="2200" dirty="0">
-                <a:latin typeface="Arial" panose="020B0604020202020204" pitchFamily="34" charset="0"/>
-                <a:cs typeface="Arial" panose="020B0604020202020204" pitchFamily="34" charset="0"/>
-              </a:rPr>
-              <a:t>=2000 </a:t>
-            </a:r>
-            <a:r>
-              <a:rPr lang="zh-CN" altLang="en-US" sz="2200" dirty="0">
-                <a:latin typeface="Arial" panose="020B0604020202020204" pitchFamily="34" charset="0"/>
-                <a:cs typeface="Arial" panose="020B0604020202020204" pitchFamily="34" charset="0"/>
-              </a:rPr>
-              <a:t>检查取得 </a:t>
-            </a:r>
-            <a:r>
-              <a:rPr lang="en-US" altLang="zh-CN" sz="2200" dirty="0">
-                <a:latin typeface="Arial" panose="020B0604020202020204" pitchFamily="34" charset="0"/>
-                <a:cs typeface="Arial" panose="020B0604020202020204" pitchFamily="34" charset="0"/>
-              </a:rPr>
-              <a:t>1 </a:t>
-            </a:r>
-            <a:r>
-              <a:rPr lang="zh-CN" altLang="en-US" sz="2200" dirty="0">
-                <a:latin typeface="Arial" panose="020B0604020202020204" pitchFamily="34" charset="0"/>
-                <a:cs typeface="Arial" panose="020B0604020202020204" pitchFamily="34" charset="0"/>
-              </a:rPr>
-              <a:t>条，要求至少 </a:t>
-            </a:r>
-            <a:r>
-              <a:rPr lang="en-US" altLang="zh-CN" sz="2200" dirty="0">
-                <a:latin typeface="Arial" panose="020B0604020202020204" pitchFamily="34" charset="0"/>
-                <a:cs typeface="Arial" panose="020B0604020202020204" pitchFamily="34" charset="0"/>
-              </a:rPr>
-              <a:t>2 </a:t>
-            </a:r>
-            <a:r>
-              <a:rPr lang="zh-CN" altLang="en-US" sz="2200" dirty="0">
-                <a:latin typeface="Arial" panose="020B0604020202020204" pitchFamily="34" charset="0"/>
-                <a:cs typeface="Arial" panose="020B0604020202020204" pitchFamily="34" charset="0"/>
-              </a:rPr>
-              <a:t>条</a:t>
+              <a:t>period</a:t>
             </a:r>
             <a:endParaRPr lang="en-CN" sz="2200" dirty="0">
               <a:latin typeface="Arial" panose="020B0604020202020204" pitchFamily="34" charset="0"/>
@@ -37512,7 +37463,7 @@
                 <a:latin typeface="Consolas" panose="020B0609020204030204" pitchFamily="49" charset="0"/>
                 <a:cs typeface="Consolas" panose="020B0609020204030204" pitchFamily="49" charset="0"/>
               </a:rPr>
-              <a:t>组长每 </a:t>
+              <a:t>组长连续计数 </a:t>
             </a:r>
             <a:r>
               <a:rPr lang="en-US" altLang="zh-CN" sz="2100" dirty="0">
@@ -37526,7 +37477,7 @@
                 <a:latin typeface="Consolas" panose="020B0609020204030204" pitchFamily="49" charset="0"/>
                 <a:cs typeface="Consolas" panose="020B0609020204030204" pitchFamily="49" charset="0"/>
               </a:rPr>
-              <a:t>个周期采样，记录中附带整组计数</a:t>
+              <a:t>个周期后请求采样，记录中附带整组计数</a:t>
             </a:r>
             <a:endParaRPr lang="en-CN" sz="2100" dirty="0">
               <a:latin typeface="Consolas" panose="020B0609020204030204" pitchFamily="49" charset="0"/>
@@ -37687,14 +37638,14 @@
           <p:nvPr>
             <p:extLst>
               <p:ext uri="{D42A27DB-BD31-4B8C-83A1-F6EECF244321}">
-                <p14:modId xmlns:p14="http://schemas.microsoft.com/office/powerpoint/2010/main" val="969270192"/>
+                <p14:modId xmlns:p14="http://schemas.microsoft.com/office/powerpoint/2010/main" val="1736286047"/>
               </p:ext>
             </p:extLst>
           </p:nvPr>
         </p:nvGraphicFramePr>
         <p:xfrm>
           <a:off x="838799" y="1656000"/>
-          <a:ext cx="10512000" cy="4269600"/>
+          <a:ext cx="10512000" cy="4741740"/>
         </p:xfrm>
         <a:graphic>
           <a:graphicData uri="http://schemas.openxmlformats.org/drawingml/2006/table">
@@ -38061,7 +38012,7 @@
                     <a:p>
                       <a:r>
                         <a:rPr lang="zh-CN" altLang="en-US" sz="2000" dirty="0"/>
-                        <a:t>组长累计 </a:t>
+                        <a:t>已处理溢出的 </a:t>
                       </a:r>
                       <a:r>
                         <a:rPr lang="en-US" altLang="zh-CN" sz="2000" dirty="0"/>
@@ -38069,7 +38020,7 @@
                       </a:r>
                       <a:r>
                         <a:rPr lang="zh-CN" altLang="en-US" sz="2000" dirty="0"/>
-                        <a:t>与 </a:t>
+                        <a:t>合计、</a:t>
                       </a:r>
                       <a:r>
                         <a:rPr lang="en-US" altLang="zh-CN" sz="2000" dirty="0"/>
@@ -39748,7 +39699,7 @@
               <a:t>acc </a:t>
             </a:r>
             <a:r>
-              <a:rPr lang="zh-CN" altLang="en-US"/>
+              <a:rPr lang="zh-CN" altLang="en-US" dirty="0"/>
               <a:t>为历史值，当前硬件增量另行加入</a:t>
             </a:r>
             <a:endParaRPr lang="en-CN" dirty="0"/>

</xml_diff>